<commit_message>
Update competitive comparison to feature Vyapar/Marg instead of ERPNext
Replace ERPNext with Vyapar/Marg in the competitive comparison slide, updating feature comparison data and footnote in the pitch deck.

Replit-Commit-Author: Agent
Replit-Commit-Session-Id: e70c97c4-e099-455a-b9ae-aa9a0dedb718
Replit-Commit-Checkpoint-Type: full_checkpoint
Replit-Commit-Event-Id: ca2248d4-e4cb-44f5-b565-ec2e26212faf
Replit-Commit-Screenshot-Url: https://storage.googleapis.com/screenshot-production-us-central1/713657ac-53c6-43a9-97a8-ef2697ef92d9/e70c97c4-e099-455a-b9ae-aa9a0dedb718/famN00F
Replit-Helium-Checkpoint-Created: true
</commit_message>
<xml_diff>
--- a/Kinto_Smart_Ops_Pitch_Deck_V5.pptx
+++ b/Kinto_Smart_Ops_Pitch_Deck_V5.pptx
@@ -9011,7 +9011,7 @@
                 <a:ea typeface="Calibri" pitchFamily="34" charset="-122"/>
                 <a:cs typeface="Calibri" pitchFamily="34" charset="-120"/>
               </a:rPr>
-              <a:t>ERPNext</a:t>
+              <a:t>Vyapar / Marg</a:t>
             </a:r>
             <a:endParaRPr lang="en-US" sz="900" dirty="0"/>
           </a:p>
@@ -9395,7 +9395,7 @@
                 <a:ea typeface="Calibri" pitchFamily="34" charset="-122"/>
                 <a:cs typeface="Calibri" pitchFamily="34" charset="-120"/>
               </a:rPr>
-              <a:t>✔ Full</a:t>
+              <a:t>✔ Basic</a:t>
             </a:r>
             <a:endParaRPr lang="en-US" sz="850" dirty="0"/>
           </a:p>
@@ -9773,13 +9773,13 @@
             <a:r>
               <a:rPr lang="en-US" sz="850" dirty="0">
                 <a:solidFill>
-                  <a:srgbClr val="15803D"/>
-                </a:solidFill>
-                <a:latin typeface="Calibri" pitchFamily="34" charset="0"/>
-                <a:ea typeface="Calibri" pitchFamily="34" charset="-122"/>
-                <a:cs typeface="Calibri" pitchFamily="34" charset="-120"/>
-              </a:rPr>
-              <a:t>✔ Full</a:t>
+                  <a:srgbClr val="9CA3AF"/>
+                </a:solidFill>
+                <a:latin typeface="Calibri" pitchFamily="34" charset="0"/>
+                <a:ea typeface="Calibri" pitchFamily="34" charset="-122"/>
+                <a:cs typeface="Calibri" pitchFamily="34" charset="-120"/>
+              </a:rPr>
+              <a:t>✘ None</a:t>
             </a:r>
             <a:endParaRPr lang="en-US" sz="850" dirty="0"/>
           </a:p>
@@ -10541,13 +10541,13 @@
             <a:r>
               <a:rPr lang="en-US" sz="850" dirty="0">
                 <a:solidFill>
-                  <a:srgbClr val="15803D"/>
-                </a:solidFill>
-                <a:latin typeface="Calibri" pitchFamily="34" charset="0"/>
-                <a:ea typeface="Calibri" pitchFamily="34" charset="-122"/>
-                <a:cs typeface="Calibri" pitchFamily="34" charset="-120"/>
-              </a:rPr>
-              <a:t>✔ Full</a:t>
+                  <a:srgbClr val="9CA3AF"/>
+                </a:solidFill>
+                <a:latin typeface="Calibri" pitchFamily="34" charset="0"/>
+                <a:ea typeface="Calibri" pitchFamily="34" charset="-122"/>
+                <a:cs typeface="Calibri" pitchFamily="34" charset="-120"/>
+              </a:rPr>
+              <a:t>✘ None</a:t>
             </a:r>
             <a:endParaRPr lang="en-US" sz="850" dirty="0"/>
           </a:p>
@@ -10925,13 +10925,13 @@
             <a:r>
               <a:rPr lang="en-US" sz="850" dirty="0">
                 <a:solidFill>
-                  <a:srgbClr val="15803D"/>
-                </a:solidFill>
-                <a:latin typeface="Calibri" pitchFamily="34" charset="0"/>
-                <a:ea typeface="Calibri" pitchFamily="34" charset="-122"/>
-                <a:cs typeface="Calibri" pitchFamily="34" charset="-120"/>
-              </a:rPr>
-              <a:t>✔ Full</a:t>
+                  <a:srgbClr val="9CA3AF"/>
+                </a:solidFill>
+                <a:latin typeface="Calibri" pitchFamily="34" charset="0"/>
+                <a:ea typeface="Calibri" pitchFamily="34" charset="-122"/>
+                <a:cs typeface="Calibri" pitchFamily="34" charset="-120"/>
+              </a:rPr>
+              <a:t>✘ None</a:t>
             </a:r>
             <a:endParaRPr lang="en-US" sz="850" dirty="0"/>
           </a:p>
@@ -11309,13 +11309,13 @@
             <a:r>
               <a:rPr lang="en-US" sz="850" dirty="0">
                 <a:solidFill>
-                  <a:srgbClr val="D97706"/>
-                </a:solidFill>
-                <a:latin typeface="Calibri" pitchFamily="34" charset="0"/>
-                <a:ea typeface="Calibri" pitchFamily="34" charset="-122"/>
-                <a:cs typeface="Calibri" pitchFamily="34" charset="-120"/>
-              </a:rPr>
-              <a:t>⚠ Basic</a:t>
+                  <a:srgbClr val="9CA3AF"/>
+                </a:solidFill>
+                <a:latin typeface="Calibri" pitchFamily="34" charset="0"/>
+                <a:ea typeface="Calibri" pitchFamily="34" charset="-122"/>
+                <a:cs typeface="Calibri" pitchFamily="34" charset="-120"/>
+              </a:rPr>
+              <a:t>✘ None</a:t>
             </a:r>
             <a:endParaRPr lang="en-US" sz="850" dirty="0"/>
           </a:p>
@@ -11693,13 +11693,13 @@
             <a:r>
               <a:rPr lang="en-US" sz="850" dirty="0">
                 <a:solidFill>
-                  <a:srgbClr val="15803D"/>
-                </a:solidFill>
-                <a:latin typeface="Calibri" pitchFamily="34" charset="0"/>
-                <a:ea typeface="Calibri" pitchFamily="34" charset="-122"/>
-                <a:cs typeface="Calibri" pitchFamily="34" charset="-120"/>
-              </a:rPr>
-              <a:t>✔ Full</a:t>
+                  <a:srgbClr val="9CA3AF"/>
+                </a:solidFill>
+                <a:latin typeface="Calibri" pitchFamily="34" charset="0"/>
+                <a:ea typeface="Calibri" pitchFamily="34" charset="-122"/>
+                <a:cs typeface="Calibri" pitchFamily="34" charset="-120"/>
+              </a:rPr>
+              <a:t>✘ None</a:t>
             </a:r>
             <a:endParaRPr lang="en-US" sz="850" dirty="0"/>
           </a:p>
@@ -12077,13 +12077,13 @@
             <a:r>
               <a:rPr lang="en-US" sz="850" dirty="0">
                 <a:solidFill>
-                  <a:srgbClr val="15803D"/>
-                </a:solidFill>
-                <a:latin typeface="Calibri" pitchFamily="34" charset="0"/>
-                <a:ea typeface="Calibri" pitchFamily="34" charset="-122"/>
-                <a:cs typeface="Calibri" pitchFamily="34" charset="-120"/>
-              </a:rPr>
-              <a:t>✔ Yes</a:t>
+                  <a:srgbClr val="D97706"/>
+                </a:solidFill>
+                <a:latin typeface="Calibri" pitchFamily="34" charset="0"/>
+                <a:ea typeface="Calibri" pitchFamily="34" charset="-122"/>
+                <a:cs typeface="Calibri" pitchFamily="34" charset="-120"/>
+              </a:rPr>
+              <a:t>⚠ Mobile</a:t>
             </a:r>
             <a:endParaRPr lang="en-US" sz="850" dirty="0"/>
           </a:p>
@@ -12467,7 +12467,7 @@
                 <a:ea typeface="Calibri" pitchFamily="34" charset="-122"/>
                 <a:cs typeface="Calibri" pitchFamily="34" charset="-120"/>
               </a:rPr>
-              <a:t>2–4 weeks</a:t>
+              <a:t>1–2 days</a:t>
             </a:r>
             <a:endParaRPr lang="en-US" sz="850" dirty="0"/>
           </a:p>
@@ -12851,7 +12851,7 @@
                 <a:ea typeface="Calibri" pitchFamily="34" charset="-122"/>
                 <a:cs typeface="Calibri" pitchFamily="34" charset="-120"/>
               </a:rPr>
-              <a:t>Free*</a:t>
+              <a:t>₹1,099/yr</a:t>
             </a:r>
             <a:endParaRPr lang="en-US" sz="850" dirty="0"/>
           </a:p>
@@ -13235,7 +13235,7 @@
                 <a:ea typeface="Calibri" pitchFamily="34" charset="-122"/>
                 <a:cs typeface="Calibri" pitchFamily="34" charset="-120"/>
               </a:rPr>
-              <a:t>Community</a:t>
+              <a:t>Basic</a:t>
             </a:r>
             <a:endParaRPr lang="en-US" sz="850" dirty="0"/>
           </a:p>
@@ -13306,17 +13306,17 @@
               <a:buNone/>
             </a:pPr>
             <a:r>
-              <a:rPr lang="en-US" sz="750" i="1" dirty="0">
-                <a:solidFill>
-                  <a:srgbClr val="64748B"/>
-                </a:solidFill>
-                <a:latin typeface="Calibri" pitchFamily="34" charset="0"/>
-                <a:ea typeface="Calibri" pitchFamily="34" charset="-122"/>
-                <a:cs typeface="Calibri" pitchFamily="34" charset="-120"/>
-              </a:rPr>
-              <a:t>* ERPNext is open-source but requires significant IT setup cost and expertise.</a:t>
-            </a:r>
-            <a:endParaRPr lang="en-US" sz="750" dirty="0"/>
+              <a:rPr lang="en-US" sz="800" b="1" dirty="0">
+                <a:solidFill>
+                  <a:srgbClr val="2563EB"/>
+                </a:solidFill>
+                <a:latin typeface="Calibri" pitchFamily="34" charset="0"/>
+                <a:ea typeface="Calibri" pitchFamily="34" charset="-122"/>
+                <a:cs typeface="Calibri" pitchFamily="34" charset="-120"/>
+              </a:rPr>
+              <a:t>Kinto Smart Ops is the only solution that covers Manufacturing + HR &amp; Payroll + CRM + WhatsApp natively in a single platform.</a:t>
+            </a:r>
+            <a:endParaRPr lang="en-US" sz="800" dirty="0"/>
           </a:p>
         </p:txBody>
       </p:sp>

</xml_diff>

<commit_message>
Update competitive analysis to include Odoo
Replace SAP B1 / MS Dynamics with Odoo in the competitive comparison table, updating relevant features and pricing data.

Replit-Commit-Author: Agent
Replit-Commit-Session-Id: e70c97c4-e099-455a-b9ae-aa9a0dedb718
Replit-Commit-Checkpoint-Type: full_checkpoint
Replit-Commit-Event-Id: fd9fd81e-73a7-44d0-a388-b68dd25f63ab
Replit-Commit-Screenshot-Url: https://storage.googleapis.com/screenshot-production-us-central1/713657ac-53c6-43a9-97a8-ef2697ef92d9/e70c97c4-e099-455a-b9ae-aa9a0dedb718/famN00F
Replit-Helium-Checkpoint-Created: true
</commit_message>
<xml_diff>
--- a/Kinto_Smart_Ops_Pitch_Deck_V5.pptx
+++ b/Kinto_Smart_Ops_Pitch_Deck_V5.pptx
@@ -8952,7 +8952,7 @@
                 <a:ea typeface="Calibri" pitchFamily="34" charset="-122"/>
                 <a:cs typeface="Calibri" pitchFamily="34" charset="-120"/>
               </a:rPr>
-              <a:t>SAP B1 / MS Dynamics</a:t>
+              <a:t>Odoo</a:t>
             </a:r>
             <a:endParaRPr lang="en-US" sz="900" dirty="0"/>
           </a:p>
@@ -10227,7 +10227,7 @@
                 <a:ea typeface="Calibri" pitchFamily="34" charset="-122"/>
                 <a:cs typeface="Calibri" pitchFamily="34" charset="-120"/>
               </a:rPr>
-              <a:t>HR &amp; Payroll Built-In</a:t>
+              <a:t>Indian HR &amp; Payroll</a:t>
             </a:r>
             <a:endParaRPr lang="en-US" sz="900" dirty="0"/>
           </a:p>
@@ -10483,7 +10483,7 @@
                 <a:ea typeface="Calibri" pitchFamily="34" charset="-122"/>
                 <a:cs typeface="Calibri" pitchFamily="34" charset="-120"/>
               </a:rPr>
-              <a:t>⚠ Add-on</a:t>
+              <a:t>⚠ Needs custom</a:t>
             </a:r>
             <a:endParaRPr lang="en-US" sz="850" dirty="0"/>
           </a:p>
@@ -10861,13 +10861,13 @@
             <a:r>
               <a:rPr lang="en-US" sz="850" dirty="0">
                 <a:solidFill>
-                  <a:srgbClr val="D97706"/>
-                </a:solidFill>
-                <a:latin typeface="Calibri" pitchFamily="34" charset="0"/>
-                <a:ea typeface="Calibri" pitchFamily="34" charset="-122"/>
-                <a:cs typeface="Calibri" pitchFamily="34" charset="-120"/>
-              </a:rPr>
-              <a:t>⚠ Add-on</a:t>
+                  <a:srgbClr val="15803D"/>
+                </a:solidFill>
+                <a:latin typeface="Calibri" pitchFamily="34" charset="0"/>
+                <a:ea typeface="Calibri" pitchFamily="34" charset="-122"/>
+                <a:cs typeface="Calibri" pitchFamily="34" charset="-120"/>
+              </a:rPr>
+              <a:t>✔ Full</a:t>
             </a:r>
             <a:endParaRPr lang="en-US" sz="850" dirty="0"/>
           </a:p>
@@ -10995,7 +10995,7 @@
                 <a:ea typeface="Calibri" pitchFamily="34" charset="-122"/>
                 <a:cs typeface="Calibri" pitchFamily="34" charset="-120"/>
               </a:rPr>
-              <a:t>Employee Self-Service Portal</a:t>
+              <a:t>Employee Self-Service</a:t>
             </a:r>
             <a:endParaRPr lang="en-US" sz="900" dirty="0"/>
           </a:p>
@@ -11251,7 +11251,7 @@
                 <a:ea typeface="Calibri" pitchFamily="34" charset="-122"/>
                 <a:cs typeface="Calibri" pitchFamily="34" charset="-120"/>
               </a:rPr>
-              <a:t>⚠ Add-on</a:t>
+              <a:t>⚠ Basic</a:t>
             </a:r>
             <a:endParaRPr lang="en-US" sz="850" dirty="0"/>
           </a:p>
@@ -11635,7 +11635,7 @@
                 <a:ea typeface="Calibri" pitchFamily="34" charset="-122"/>
                 <a:cs typeface="Calibri" pitchFamily="34" charset="-120"/>
               </a:rPr>
-              <a:t>⚠ Add-on</a:t>
+              <a:t>⚠ Enterprise+</a:t>
             </a:r>
             <a:endParaRPr lang="en-US" sz="850" dirty="0"/>
           </a:p>
@@ -12403,7 +12403,7 @@
                 <a:ea typeface="Calibri" pitchFamily="34" charset="-122"/>
                 <a:cs typeface="Calibri" pitchFamily="34" charset="-120"/>
               </a:rPr>
-              <a:t>3–6 months</a:t>
+              <a:t>2–4 months</a:t>
             </a:r>
             <a:endParaRPr lang="en-US" sz="850" dirty="0"/>
           </a:p>
@@ -12787,7 +12787,7 @@
                 <a:ea typeface="Calibri" pitchFamily="34" charset="-122"/>
                 <a:cs typeface="Calibri" pitchFamily="34" charset="-120"/>
               </a:rPr>
-              <a:t>₹2L+/yr</a:t>
+              <a:t>₹2,500+/user</a:t>
             </a:r>
             <a:endParaRPr lang="en-US" sz="850" dirty="0"/>
           </a:p>
@@ -13171,7 +13171,7 @@
                 <a:ea typeface="Calibri" pitchFamily="34" charset="-122"/>
                 <a:cs typeface="Calibri" pitchFamily="34" charset="-120"/>
               </a:rPr>
-              <a:t>Paid</a:t>
+              <a:t>Paid (costly)</a:t>
             </a:r>
             <a:endParaRPr lang="en-US" sz="850" dirty="0"/>
           </a:p>

</xml_diff>

<commit_message>
Clarify feature availability across different service plans
Update presentation to visually tag each module with its corresponding plan (Basic, Pro, Enterprise) and adjust the main header to emphasize that all features are unlocked with the Enterprise plan at ₹2,599/month.

Replit-Commit-Author: Agent
Replit-Commit-Session-Id: e70c97c4-e099-455a-b9ae-aa9a0dedb718
Replit-Commit-Checkpoint-Type: full_checkpoint
Replit-Commit-Event-Id: c164be29-9489-4099-b5b7-e201ad5e68c4
Replit-Commit-Screenshot-Url: https://storage.googleapis.com/screenshot-production-us-central1/713657ac-53c6-43a9-97a8-ef2697ef92d9/e70c97c4-e099-455a-b9ae-aa9a0dedb718/famN00F
Replit-Helium-Checkpoint-Created: true
</commit_message>
<xml_diff>
--- a/Kinto_Smart_Ops_Pitch_Deck_V5.pptx
+++ b/Kinto_Smart_Ops_Pitch_Deck_V5.pptx
@@ -20753,7 +20753,7 @@
                 <a:ea typeface="Calibri" pitchFamily="34" charset="-122"/>
                 <a:cs typeface="Calibri" pitchFamily="34" charset="-120"/>
               </a:rPr>
-              <a:t>Everything your factory needs — all in one place</a:t>
+              <a:t>Full platform unlocked at Enterprise — ₹2,599/month</a:t>
             </a:r>
             <a:endParaRPr lang="en-US" sz="1200" dirty="0"/>
           </a:p>
@@ -20846,12 +20846,234 @@
         </p:nvSpPr>
         <p:spPr>
           <a:xfrm>
-            <a:off x="228600" y="1234440"/>
-            <a:ext cx="2194560" cy="1417320"/>
+            <a:off x="6858000" y="1170432"/>
+            <a:ext cx="1554480" cy="237744"/>
           </a:xfrm>
           <a:prstGeom prst="rect">
             <a:avLst>
-              <a:gd name="adj" fmla="val 5161"/>
+              <a:gd name="adj" fmla="val 15385"/>
+            </a:avLst>
+          </a:prstGeom>
+          <a:solidFill>
+            <a:srgbClr val="F1F5F9"/>
+          </a:solidFill>
+          <a:ln/>
+        </p:spPr>
+      </p:sp>
+      <p:sp>
+        <p:nvSpPr>
+          <p:cNvPr id="9" name="Text 7"/>
+          <p:cNvSpPr/>
+          <p:nvPr/>
+        </p:nvSpPr>
+        <p:spPr>
+          <a:xfrm>
+            <a:off x="6858000" y="1170432"/>
+            <a:ext cx="1554480" cy="237744"/>
+          </a:xfrm>
+          <a:prstGeom prst="rect">
+            <a:avLst/>
+          </a:prstGeom>
+          <a:noFill/>
+          <a:ln/>
+        </p:spPr>
+        <p:txBody>
+          <a:bodyPr wrap="square" rtlCol="0" anchor="ctr"/>
+          <a:lstStyle/>
+          <a:p>
+            <a:pPr algn="ctr" indent="0" marL="0">
+              <a:buNone/>
+            </a:pPr>
+            <a:r>
+              <a:rPr lang="en-US" sz="750" b="1" dirty="0">
+                <a:solidFill>
+                  <a:srgbClr val="64748B"/>
+                </a:solidFill>
+                <a:latin typeface="Calibri" pitchFamily="34" charset="0"/>
+                <a:ea typeface="Calibri" pitchFamily="34" charset="-122"/>
+                <a:cs typeface="Calibri" pitchFamily="34" charset="-120"/>
+              </a:rPr>
+              <a:t>BASIC</a:t>
+            </a:r>
+            <a:endParaRPr lang="en-US" sz="750" dirty="0"/>
+          </a:p>
+        </p:txBody>
+      </p:sp>
+      <p:sp>
+        <p:nvSpPr>
+          <p:cNvPr id="10" name="Shape 8"/>
+          <p:cNvSpPr/>
+          <p:nvPr/>
+        </p:nvSpPr>
+        <p:spPr>
+          <a:xfrm>
+            <a:off x="8549640" y="1170432"/>
+            <a:ext cx="1554480" cy="237744"/>
+          </a:xfrm>
+          <a:prstGeom prst="rect">
+            <a:avLst>
+              <a:gd name="adj" fmla="val 15385"/>
+            </a:avLst>
+          </a:prstGeom>
+          <a:solidFill>
+            <a:srgbClr val="DBEAFE"/>
+          </a:solidFill>
+          <a:ln/>
+        </p:spPr>
+      </p:sp>
+      <p:sp>
+        <p:nvSpPr>
+          <p:cNvPr id="11" name="Text 9"/>
+          <p:cNvSpPr/>
+          <p:nvPr/>
+        </p:nvSpPr>
+        <p:spPr>
+          <a:xfrm>
+            <a:off x="8549640" y="1170432"/>
+            <a:ext cx="1554480" cy="237744"/>
+          </a:xfrm>
+          <a:prstGeom prst="rect">
+            <a:avLst/>
+          </a:prstGeom>
+          <a:noFill/>
+          <a:ln/>
+        </p:spPr>
+        <p:txBody>
+          <a:bodyPr wrap="square" rtlCol="0" anchor="ctr"/>
+          <a:lstStyle/>
+          <a:p>
+            <a:pPr algn="ctr" indent="0" marL="0">
+              <a:buNone/>
+            </a:pPr>
+            <a:r>
+              <a:rPr lang="en-US" sz="750" b="1" dirty="0">
+                <a:solidFill>
+                  <a:srgbClr val="0369A1"/>
+                </a:solidFill>
+                <a:latin typeface="Calibri" pitchFamily="34" charset="0"/>
+                <a:ea typeface="Calibri" pitchFamily="34" charset="-122"/>
+                <a:cs typeface="Calibri" pitchFamily="34" charset="-120"/>
+              </a:rPr>
+              <a:t>PRO</a:t>
+            </a:r>
+            <a:endParaRPr lang="en-US" sz="750" dirty="0"/>
+          </a:p>
+        </p:txBody>
+      </p:sp>
+      <p:sp>
+        <p:nvSpPr>
+          <p:cNvPr id="12" name="Shape 10"/>
+          <p:cNvSpPr/>
+          <p:nvPr/>
+        </p:nvSpPr>
+        <p:spPr>
+          <a:xfrm>
+            <a:off x="10241280" y="1170432"/>
+            <a:ext cx="1554480" cy="237744"/>
+          </a:xfrm>
+          <a:prstGeom prst="rect">
+            <a:avLst>
+              <a:gd name="adj" fmla="val 15385"/>
+            </a:avLst>
+          </a:prstGeom>
+          <a:solidFill>
+            <a:srgbClr val="1E3A5F"/>
+          </a:solidFill>
+          <a:ln/>
+        </p:spPr>
+      </p:sp>
+      <p:sp>
+        <p:nvSpPr>
+          <p:cNvPr id="13" name="Text 11"/>
+          <p:cNvSpPr/>
+          <p:nvPr/>
+        </p:nvSpPr>
+        <p:spPr>
+          <a:xfrm>
+            <a:off x="10241280" y="1170432"/>
+            <a:ext cx="1554480" cy="237744"/>
+          </a:xfrm>
+          <a:prstGeom prst="rect">
+            <a:avLst/>
+          </a:prstGeom>
+          <a:noFill/>
+          <a:ln/>
+        </p:spPr>
+        <p:txBody>
+          <a:bodyPr wrap="square" rtlCol="0" anchor="ctr"/>
+          <a:lstStyle/>
+          <a:p>
+            <a:pPr algn="ctr" indent="0" marL="0">
+              <a:buNone/>
+            </a:pPr>
+            <a:r>
+              <a:rPr lang="en-US" sz="750" b="1" dirty="0">
+                <a:solidFill>
+                  <a:srgbClr val="FFFFFF"/>
+                </a:solidFill>
+                <a:latin typeface="Calibri" pitchFamily="34" charset="0"/>
+                <a:ea typeface="Calibri" pitchFamily="34" charset="-122"/>
+                <a:cs typeface="Calibri" pitchFamily="34" charset="-120"/>
+              </a:rPr>
+              <a:t>ENTERPRISE</a:t>
+            </a:r>
+            <a:endParaRPr lang="en-US" sz="750" dirty="0"/>
+          </a:p>
+        </p:txBody>
+      </p:sp>
+      <p:sp>
+        <p:nvSpPr>
+          <p:cNvPr id="14" name="Text 12"/>
+          <p:cNvSpPr/>
+          <p:nvPr/>
+        </p:nvSpPr>
+        <p:spPr>
+          <a:xfrm>
+            <a:off x="6309360" y="1170432"/>
+            <a:ext cx="548640" cy="237744"/>
+          </a:xfrm>
+          <a:prstGeom prst="rect">
+            <a:avLst/>
+          </a:prstGeom>
+          <a:noFill/>
+          <a:ln/>
+        </p:spPr>
+        <p:txBody>
+          <a:bodyPr wrap="square" rtlCol="0" anchor="ctr"/>
+          <a:lstStyle/>
+          <a:p>
+            <a:pPr indent="0" marL="0">
+              <a:buNone/>
+            </a:pPr>
+            <a:r>
+              <a:rPr lang="en-US" sz="750" dirty="0">
+                <a:solidFill>
+                  <a:srgbClr val="64748B"/>
+                </a:solidFill>
+                <a:latin typeface="Calibri" pitchFamily="34" charset="0"/>
+                <a:ea typeface="Calibri" pitchFamily="34" charset="-122"/>
+                <a:cs typeface="Calibri" pitchFamily="34" charset="-120"/>
+              </a:rPr>
+              <a:t>Plan:</a:t>
+            </a:r>
+            <a:endParaRPr lang="en-US" sz="750" dirty="0"/>
+          </a:p>
+        </p:txBody>
+      </p:sp>
+      <p:sp>
+        <p:nvSpPr>
+          <p:cNvPr id="15" name="Shape 13"/>
+          <p:cNvSpPr/>
+          <p:nvPr/>
+        </p:nvSpPr>
+        <p:spPr>
+          <a:xfrm>
+            <a:off x="228600" y="1481328"/>
+            <a:ext cx="2194560" cy="1536192"/>
+          </a:xfrm>
+          <a:prstGeom prst="rect">
+            <a:avLst>
+              <a:gd name="adj" fmla="val 4762"/>
             </a:avLst>
           </a:prstGeom>
           <a:solidFill>
@@ -20867,14 +21089,14 @@
       </p:sp>
       <p:sp>
         <p:nvSpPr>
-          <p:cNvPr id="9" name="Text 7"/>
-          <p:cNvSpPr/>
-          <p:nvPr/>
-        </p:nvSpPr>
-        <p:spPr>
-          <a:xfrm>
-            <a:off x="228600" y="1325880"/>
-            <a:ext cx="2194560" cy="1234440"/>
+          <p:cNvPr id="16" name="Text 14"/>
+          <p:cNvSpPr/>
+          <p:nvPr/>
+        </p:nvSpPr>
+        <p:spPr>
+          <a:xfrm>
+            <a:off x="301752" y="1591056"/>
+            <a:ext cx="2048256" cy="1005840"/>
           </a:xfrm>
           <a:prstGeom prst="rect">
             <a:avLst/>
@@ -20898,7 +21120,7 @@
                 <a:ea typeface="Calibri" pitchFamily="34" charset="-122"/>
                 <a:cs typeface="Calibri" pitchFamily="34" charset="-120"/>
               </a:rPr>
-              <a:t>Production Management</a:t>
+              <a:t>GST Invoicing</a:t>
             </a:r>
             <a:endParaRPr lang="en-US" sz="1050" dirty="0"/>
           </a:p>
@@ -20906,18 +21128,79 @@
       </p:sp>
       <p:sp>
         <p:nvSpPr>
-          <p:cNvPr id="10" name="Shape 8"/>
-          <p:cNvSpPr/>
-          <p:nvPr/>
-        </p:nvSpPr>
-        <p:spPr>
-          <a:xfrm>
-            <a:off x="2578608" y="1234440"/>
-            <a:ext cx="2194560" cy="1417320"/>
+          <p:cNvPr id="17" name="Shape 15"/>
+          <p:cNvSpPr/>
+          <p:nvPr/>
+        </p:nvSpPr>
+        <p:spPr>
+          <a:xfrm>
+            <a:off x="301752" y="2596896"/>
+            <a:ext cx="2048256" cy="256032"/>
           </a:xfrm>
           <a:prstGeom prst="rect">
             <a:avLst>
-              <a:gd name="adj" fmla="val 5161"/>
+              <a:gd name="adj" fmla="val 14286"/>
+            </a:avLst>
+          </a:prstGeom>
+          <a:solidFill>
+            <a:srgbClr val="F1F5F9"/>
+          </a:solidFill>
+          <a:ln/>
+        </p:spPr>
+      </p:sp>
+      <p:sp>
+        <p:nvSpPr>
+          <p:cNvPr id="18" name="Text 16"/>
+          <p:cNvSpPr/>
+          <p:nvPr/>
+        </p:nvSpPr>
+        <p:spPr>
+          <a:xfrm>
+            <a:off x="301752" y="2596896"/>
+            <a:ext cx="2048256" cy="256032"/>
+          </a:xfrm>
+          <a:prstGeom prst="rect">
+            <a:avLst/>
+          </a:prstGeom>
+          <a:noFill/>
+          <a:ln/>
+        </p:spPr>
+        <p:txBody>
+          <a:bodyPr wrap="square" rtlCol="0" anchor="ctr"/>
+          <a:lstStyle/>
+          <a:p>
+            <a:pPr algn="ctr" indent="0" marL="0">
+              <a:buNone/>
+            </a:pPr>
+            <a:r>
+              <a:rPr lang="en-US" sz="750" b="1" dirty="0">
+                <a:solidFill>
+                  <a:srgbClr val="64748B"/>
+                </a:solidFill>
+                <a:latin typeface="Calibri" pitchFamily="34" charset="0"/>
+                <a:ea typeface="Calibri" pitchFamily="34" charset="-122"/>
+                <a:cs typeface="Calibri" pitchFamily="34" charset="-120"/>
+              </a:rPr>
+              <a:t>BASIC</a:t>
+            </a:r>
+            <a:endParaRPr lang="en-US" sz="750" dirty="0"/>
+          </a:p>
+        </p:txBody>
+      </p:sp>
+      <p:sp>
+        <p:nvSpPr>
+          <p:cNvPr id="19" name="Shape 17"/>
+          <p:cNvSpPr/>
+          <p:nvPr/>
+        </p:nvSpPr>
+        <p:spPr>
+          <a:xfrm>
+            <a:off x="2578608" y="1481328"/>
+            <a:ext cx="2194560" cy="1536192"/>
+          </a:xfrm>
+          <a:prstGeom prst="rect">
+            <a:avLst>
+              <a:gd name="adj" fmla="val 4762"/>
             </a:avLst>
           </a:prstGeom>
           <a:solidFill>
@@ -20933,14 +21216,14 @@
       </p:sp>
       <p:sp>
         <p:nvSpPr>
-          <p:cNvPr id="11" name="Text 9"/>
-          <p:cNvSpPr/>
-          <p:nvPr/>
-        </p:nvSpPr>
-        <p:spPr>
-          <a:xfrm>
-            <a:off x="2578608" y="1325880"/>
-            <a:ext cx="2194560" cy="1234440"/>
+          <p:cNvPr id="20" name="Text 18"/>
+          <p:cNvSpPr/>
+          <p:nvPr/>
+        </p:nvSpPr>
+        <p:spPr>
+          <a:xfrm>
+            <a:off x="2651760" y="1591056"/>
+            <a:ext cx="2048256" cy="1005840"/>
           </a:xfrm>
           <a:prstGeom prst="rect">
             <a:avLst/>
@@ -20972,18 +21255,79 @@
       </p:sp>
       <p:sp>
         <p:nvSpPr>
-          <p:cNvPr id="12" name="Shape 10"/>
-          <p:cNvSpPr/>
-          <p:nvPr/>
-        </p:nvSpPr>
-        <p:spPr>
-          <a:xfrm>
-            <a:off x="4928616" y="1234440"/>
-            <a:ext cx="2194560" cy="1417320"/>
+          <p:cNvPr id="21" name="Shape 19"/>
+          <p:cNvSpPr/>
+          <p:nvPr/>
+        </p:nvSpPr>
+        <p:spPr>
+          <a:xfrm>
+            <a:off x="2651760" y="2596896"/>
+            <a:ext cx="2048256" cy="256032"/>
           </a:xfrm>
           <a:prstGeom prst="rect">
             <a:avLst>
-              <a:gd name="adj" fmla="val 5161"/>
+              <a:gd name="adj" fmla="val 14286"/>
+            </a:avLst>
+          </a:prstGeom>
+          <a:solidFill>
+            <a:srgbClr val="F1F5F9"/>
+          </a:solidFill>
+          <a:ln/>
+        </p:spPr>
+      </p:sp>
+      <p:sp>
+        <p:nvSpPr>
+          <p:cNvPr id="22" name="Text 20"/>
+          <p:cNvSpPr/>
+          <p:nvPr/>
+        </p:nvSpPr>
+        <p:spPr>
+          <a:xfrm>
+            <a:off x="2651760" y="2596896"/>
+            <a:ext cx="2048256" cy="256032"/>
+          </a:xfrm>
+          <a:prstGeom prst="rect">
+            <a:avLst/>
+          </a:prstGeom>
+          <a:noFill/>
+          <a:ln/>
+        </p:spPr>
+        <p:txBody>
+          <a:bodyPr wrap="square" rtlCol="0" anchor="ctr"/>
+          <a:lstStyle/>
+          <a:p>
+            <a:pPr algn="ctr" indent="0" marL="0">
+              <a:buNone/>
+            </a:pPr>
+            <a:r>
+              <a:rPr lang="en-US" sz="750" b="1" dirty="0">
+                <a:solidFill>
+                  <a:srgbClr val="64748B"/>
+                </a:solidFill>
+                <a:latin typeface="Calibri" pitchFamily="34" charset="0"/>
+                <a:ea typeface="Calibri" pitchFamily="34" charset="-122"/>
+                <a:cs typeface="Calibri" pitchFamily="34" charset="-120"/>
+              </a:rPr>
+              <a:t>BASIC</a:t>
+            </a:r>
+            <a:endParaRPr lang="en-US" sz="750" dirty="0"/>
+          </a:p>
+        </p:txBody>
+      </p:sp>
+      <p:sp>
+        <p:nvSpPr>
+          <p:cNvPr id="23" name="Shape 21"/>
+          <p:cNvSpPr/>
+          <p:nvPr/>
+        </p:nvSpPr>
+        <p:spPr>
+          <a:xfrm>
+            <a:off x="4928616" y="1481328"/>
+            <a:ext cx="2194560" cy="1536192"/>
+          </a:xfrm>
+          <a:prstGeom prst="rect">
+            <a:avLst>
+              <a:gd name="adj" fmla="val 4762"/>
             </a:avLst>
           </a:prstGeom>
           <a:solidFill>
@@ -20999,14 +21343,14 @@
       </p:sp>
       <p:sp>
         <p:nvSpPr>
-          <p:cNvPr id="13" name="Text 11"/>
-          <p:cNvSpPr/>
-          <p:nvPr/>
-        </p:nvSpPr>
-        <p:spPr>
-          <a:xfrm>
-            <a:off x="4928616" y="1325880"/>
-            <a:ext cx="2194560" cy="1234440"/>
+          <p:cNvPr id="24" name="Text 22"/>
+          <p:cNvSpPr/>
+          <p:nvPr/>
+        </p:nvSpPr>
+        <p:spPr>
+          <a:xfrm>
+            <a:off x="5001768" y="1591056"/>
+            <a:ext cx="2048256" cy="1005840"/>
           </a:xfrm>
           <a:prstGeom prst="rect">
             <a:avLst/>
@@ -21038,18 +21382,79 @@
       </p:sp>
       <p:sp>
         <p:nvSpPr>
-          <p:cNvPr id="14" name="Shape 12"/>
-          <p:cNvSpPr/>
-          <p:nvPr/>
-        </p:nvSpPr>
-        <p:spPr>
-          <a:xfrm>
-            <a:off x="7278624" y="1234440"/>
-            <a:ext cx="2194560" cy="1417320"/>
+          <p:cNvPr id="25" name="Shape 23"/>
+          <p:cNvSpPr/>
+          <p:nvPr/>
+        </p:nvSpPr>
+        <p:spPr>
+          <a:xfrm>
+            <a:off x="5001768" y="2596896"/>
+            <a:ext cx="2048256" cy="256032"/>
           </a:xfrm>
           <a:prstGeom prst="rect">
             <a:avLst>
-              <a:gd name="adj" fmla="val 5161"/>
+              <a:gd name="adj" fmla="val 14286"/>
+            </a:avLst>
+          </a:prstGeom>
+          <a:solidFill>
+            <a:srgbClr val="F1F5F9"/>
+          </a:solidFill>
+          <a:ln/>
+        </p:spPr>
+      </p:sp>
+      <p:sp>
+        <p:nvSpPr>
+          <p:cNvPr id="26" name="Text 24"/>
+          <p:cNvSpPr/>
+          <p:nvPr/>
+        </p:nvSpPr>
+        <p:spPr>
+          <a:xfrm>
+            <a:off x="5001768" y="2596896"/>
+            <a:ext cx="2048256" cy="256032"/>
+          </a:xfrm>
+          <a:prstGeom prst="rect">
+            <a:avLst/>
+          </a:prstGeom>
+          <a:noFill/>
+          <a:ln/>
+        </p:spPr>
+        <p:txBody>
+          <a:bodyPr wrap="square" rtlCol="0" anchor="ctr"/>
+          <a:lstStyle/>
+          <a:p>
+            <a:pPr algn="ctr" indent="0" marL="0">
+              <a:buNone/>
+            </a:pPr>
+            <a:r>
+              <a:rPr lang="en-US" sz="750" b="1" dirty="0">
+                <a:solidFill>
+                  <a:srgbClr val="64748B"/>
+                </a:solidFill>
+                <a:latin typeface="Calibri" pitchFamily="34" charset="0"/>
+                <a:ea typeface="Calibri" pitchFamily="34" charset="-122"/>
+                <a:cs typeface="Calibri" pitchFamily="34" charset="-120"/>
+              </a:rPr>
+              <a:t>BASIC</a:t>
+            </a:r>
+            <a:endParaRPr lang="en-US" sz="750" dirty="0"/>
+          </a:p>
+        </p:txBody>
+      </p:sp>
+      <p:sp>
+        <p:nvSpPr>
+          <p:cNvPr id="27" name="Shape 25"/>
+          <p:cNvSpPr/>
+          <p:nvPr/>
+        </p:nvSpPr>
+        <p:spPr>
+          <a:xfrm>
+            <a:off x="7278624" y="1481328"/>
+            <a:ext cx="2194560" cy="1536192"/>
+          </a:xfrm>
+          <a:prstGeom prst="rect">
+            <a:avLst>
+              <a:gd name="adj" fmla="val 4762"/>
             </a:avLst>
           </a:prstGeom>
           <a:solidFill>
@@ -21065,14 +21470,14 @@
       </p:sp>
       <p:sp>
         <p:nvSpPr>
-          <p:cNvPr id="15" name="Text 13"/>
-          <p:cNvSpPr/>
-          <p:nvPr/>
-        </p:nvSpPr>
-        <p:spPr>
-          <a:xfrm>
-            <a:off x="7278624" y="1325880"/>
-            <a:ext cx="2194560" cy="1234440"/>
+          <p:cNvPr id="28" name="Text 26"/>
+          <p:cNvSpPr/>
+          <p:nvPr/>
+        </p:nvSpPr>
+        <p:spPr>
+          <a:xfrm>
+            <a:off x="7351776" y="1591056"/>
+            <a:ext cx="2048256" cy="1005840"/>
           </a:xfrm>
           <a:prstGeom prst="rect">
             <a:avLst/>
@@ -21096,7 +21501,7 @@
                 <a:ea typeface="Calibri" pitchFamily="34" charset="-122"/>
                 <a:cs typeface="Calibri" pitchFamily="34" charset="-120"/>
               </a:rPr>
-              <a:t>GST Invoicing</a:t>
+              <a:t>Dispatch &amp; Gatepasses</a:t>
             </a:r>
             <a:endParaRPr lang="en-US" sz="1050" dirty="0"/>
           </a:p>
@@ -21104,18 +21509,79 @@
       </p:sp>
       <p:sp>
         <p:nvSpPr>
-          <p:cNvPr id="16" name="Shape 14"/>
-          <p:cNvSpPr/>
-          <p:nvPr/>
-        </p:nvSpPr>
-        <p:spPr>
-          <a:xfrm>
-            <a:off x="9628632" y="1234440"/>
-            <a:ext cx="2194560" cy="1417320"/>
+          <p:cNvPr id="29" name="Shape 27"/>
+          <p:cNvSpPr/>
+          <p:nvPr/>
+        </p:nvSpPr>
+        <p:spPr>
+          <a:xfrm>
+            <a:off x="7351776" y="2596896"/>
+            <a:ext cx="2048256" cy="256032"/>
           </a:xfrm>
           <a:prstGeom prst="rect">
             <a:avLst>
-              <a:gd name="adj" fmla="val 5161"/>
+              <a:gd name="adj" fmla="val 14286"/>
+            </a:avLst>
+          </a:prstGeom>
+          <a:solidFill>
+            <a:srgbClr val="F1F5F9"/>
+          </a:solidFill>
+          <a:ln/>
+        </p:spPr>
+      </p:sp>
+      <p:sp>
+        <p:nvSpPr>
+          <p:cNvPr id="30" name="Text 28"/>
+          <p:cNvSpPr/>
+          <p:nvPr/>
+        </p:nvSpPr>
+        <p:spPr>
+          <a:xfrm>
+            <a:off x="7351776" y="2596896"/>
+            <a:ext cx="2048256" cy="256032"/>
+          </a:xfrm>
+          <a:prstGeom prst="rect">
+            <a:avLst/>
+          </a:prstGeom>
+          <a:noFill/>
+          <a:ln/>
+        </p:spPr>
+        <p:txBody>
+          <a:bodyPr wrap="square" rtlCol="0" anchor="ctr"/>
+          <a:lstStyle/>
+          <a:p>
+            <a:pPr algn="ctr" indent="0" marL="0">
+              <a:buNone/>
+            </a:pPr>
+            <a:r>
+              <a:rPr lang="en-US" sz="750" b="1" dirty="0">
+                <a:solidFill>
+                  <a:srgbClr val="64748B"/>
+                </a:solidFill>
+                <a:latin typeface="Calibri" pitchFamily="34" charset="0"/>
+                <a:ea typeface="Calibri" pitchFamily="34" charset="-122"/>
+                <a:cs typeface="Calibri" pitchFamily="34" charset="-120"/>
+              </a:rPr>
+              <a:t>BASIC</a:t>
+            </a:r>
+            <a:endParaRPr lang="en-US" sz="750" dirty="0"/>
+          </a:p>
+        </p:txBody>
+      </p:sp>
+      <p:sp>
+        <p:nvSpPr>
+          <p:cNvPr id="31" name="Shape 29"/>
+          <p:cNvSpPr/>
+          <p:nvPr/>
+        </p:nvSpPr>
+        <p:spPr>
+          <a:xfrm>
+            <a:off x="9628632" y="1481328"/>
+            <a:ext cx="2194560" cy="1536192"/>
+          </a:xfrm>
+          <a:prstGeom prst="rect">
+            <a:avLst>
+              <a:gd name="adj" fmla="val 4762"/>
             </a:avLst>
           </a:prstGeom>
           <a:solidFill>
@@ -21131,14 +21597,14 @@
       </p:sp>
       <p:sp>
         <p:nvSpPr>
-          <p:cNvPr id="17" name="Text 15"/>
-          <p:cNvSpPr/>
-          <p:nvPr/>
-        </p:nvSpPr>
-        <p:spPr>
-          <a:xfrm>
-            <a:off x="9628632" y="1325880"/>
-            <a:ext cx="2194560" cy="1234440"/>
+          <p:cNvPr id="32" name="Text 30"/>
+          <p:cNvSpPr/>
+          <p:nvPr/>
+        </p:nvSpPr>
+        <p:spPr>
+          <a:xfrm>
+            <a:off x="9701784" y="1591056"/>
+            <a:ext cx="2048256" cy="1005840"/>
           </a:xfrm>
           <a:prstGeom prst="rect">
             <a:avLst/>
@@ -21162,7 +21628,7 @@
                 <a:ea typeface="Calibri" pitchFamily="34" charset="-122"/>
                 <a:cs typeface="Calibri" pitchFamily="34" charset="-120"/>
               </a:rPr>
-              <a:t>Dispatch &amp; Gatepasses</a:t>
+              <a:t>Expenses &amp; Cash Register</a:t>
             </a:r>
             <a:endParaRPr lang="en-US" sz="1050" dirty="0"/>
           </a:p>
@@ -21170,22 +21636,83 @@
       </p:sp>
       <p:sp>
         <p:nvSpPr>
-          <p:cNvPr id="18" name="Shape 16"/>
-          <p:cNvSpPr/>
-          <p:nvPr/>
-        </p:nvSpPr>
-        <p:spPr>
-          <a:xfrm>
-            <a:off x="228600" y="2834640"/>
-            <a:ext cx="2194560" cy="1417320"/>
+          <p:cNvPr id="33" name="Shape 31"/>
+          <p:cNvSpPr/>
+          <p:nvPr/>
+        </p:nvSpPr>
+        <p:spPr>
+          <a:xfrm>
+            <a:off x="9701784" y="2596896"/>
+            <a:ext cx="2048256" cy="256032"/>
           </a:xfrm>
           <a:prstGeom prst="rect">
             <a:avLst>
-              <a:gd name="adj" fmla="val 5161"/>
+              <a:gd name="adj" fmla="val 14286"/>
             </a:avLst>
           </a:prstGeom>
           <a:solidFill>
-            <a:srgbClr val="FFFFFF"/>
+            <a:srgbClr val="F1F5F9"/>
+          </a:solidFill>
+          <a:ln/>
+        </p:spPr>
+      </p:sp>
+      <p:sp>
+        <p:nvSpPr>
+          <p:cNvPr id="34" name="Text 32"/>
+          <p:cNvSpPr/>
+          <p:nvPr/>
+        </p:nvSpPr>
+        <p:spPr>
+          <a:xfrm>
+            <a:off x="9701784" y="2596896"/>
+            <a:ext cx="2048256" cy="256032"/>
+          </a:xfrm>
+          <a:prstGeom prst="rect">
+            <a:avLst/>
+          </a:prstGeom>
+          <a:noFill/>
+          <a:ln/>
+        </p:spPr>
+        <p:txBody>
+          <a:bodyPr wrap="square" rtlCol="0" anchor="ctr"/>
+          <a:lstStyle/>
+          <a:p>
+            <a:pPr algn="ctr" indent="0" marL="0">
+              <a:buNone/>
+            </a:pPr>
+            <a:r>
+              <a:rPr lang="en-US" sz="750" b="1" dirty="0">
+                <a:solidFill>
+                  <a:srgbClr val="64748B"/>
+                </a:solidFill>
+                <a:latin typeface="Calibri" pitchFamily="34" charset="0"/>
+                <a:ea typeface="Calibri" pitchFamily="34" charset="-122"/>
+                <a:cs typeface="Calibri" pitchFamily="34" charset="-120"/>
+              </a:rPr>
+              <a:t>BASIC</a:t>
+            </a:r>
+            <a:endParaRPr lang="en-US" sz="750" dirty="0"/>
+          </a:p>
+        </p:txBody>
+      </p:sp>
+      <p:sp>
+        <p:nvSpPr>
+          <p:cNvPr id="35" name="Shape 33"/>
+          <p:cNvSpPr/>
+          <p:nvPr/>
+        </p:nvSpPr>
+        <p:spPr>
+          <a:xfrm>
+            <a:off x="228600" y="3200400"/>
+            <a:ext cx="2194560" cy="1536192"/>
+          </a:xfrm>
+          <a:prstGeom prst="rect">
+            <a:avLst>
+              <a:gd name="adj" fmla="val 4762"/>
+            </a:avLst>
+          </a:prstGeom>
+          <a:solidFill>
+            <a:srgbClr val="EFF6FF"/>
           </a:solidFill>
           <a:ln w="12700">
             <a:solidFill>
@@ -21197,14 +21724,14 @@
       </p:sp>
       <p:sp>
         <p:nvSpPr>
-          <p:cNvPr id="19" name="Text 17"/>
-          <p:cNvSpPr/>
-          <p:nvPr/>
-        </p:nvSpPr>
-        <p:spPr>
-          <a:xfrm>
-            <a:off x="228600" y="2926080"/>
-            <a:ext cx="2194560" cy="1234440"/>
+          <p:cNvPr id="36" name="Text 34"/>
+          <p:cNvSpPr/>
+          <p:nvPr/>
+        </p:nvSpPr>
+        <p:spPr>
+          <a:xfrm>
+            <a:off x="301752" y="3310128"/>
+            <a:ext cx="2048256" cy="1005840"/>
           </a:xfrm>
           <a:prstGeom prst="rect">
             <a:avLst/>
@@ -21222,13 +21749,13 @@
             <a:r>
               <a:rPr lang="en-US" sz="1050" b="1" dirty="0">
                 <a:solidFill>
-                  <a:srgbClr val="1E3A5F"/>
-                </a:solidFill>
-                <a:latin typeface="Calibri" pitchFamily="34" charset="0"/>
-                <a:ea typeface="Calibri" pitchFamily="34" charset="-122"/>
-                <a:cs typeface="Calibri" pitchFamily="34" charset="-120"/>
-              </a:rPr>
-              <a:t>Quality &amp; Returns</a:t>
+                  <a:srgbClr val="0369A1"/>
+                </a:solidFill>
+                <a:latin typeface="Calibri" pitchFamily="34" charset="0"/>
+                <a:ea typeface="Calibri" pitchFamily="34" charset="-122"/>
+                <a:cs typeface="Calibri" pitchFamily="34" charset="-120"/>
+              </a:rPr>
+              <a:t>Production Management</a:t>
             </a:r>
             <a:endParaRPr lang="en-US" sz="1050" dirty="0"/>
           </a:p>
@@ -21236,22 +21763,83 @@
       </p:sp>
       <p:sp>
         <p:nvSpPr>
-          <p:cNvPr id="20" name="Shape 18"/>
-          <p:cNvSpPr/>
-          <p:nvPr/>
-        </p:nvSpPr>
-        <p:spPr>
-          <a:xfrm>
-            <a:off x="2578608" y="2834640"/>
-            <a:ext cx="2194560" cy="1417320"/>
+          <p:cNvPr id="37" name="Shape 35"/>
+          <p:cNvSpPr/>
+          <p:nvPr/>
+        </p:nvSpPr>
+        <p:spPr>
+          <a:xfrm>
+            <a:off x="301752" y="4315968"/>
+            <a:ext cx="2048256" cy="256032"/>
           </a:xfrm>
           <a:prstGeom prst="rect">
             <a:avLst>
-              <a:gd name="adj" fmla="val 5161"/>
+              <a:gd name="adj" fmla="val 14286"/>
             </a:avLst>
           </a:prstGeom>
           <a:solidFill>
-            <a:srgbClr val="FFFFFF"/>
+            <a:srgbClr val="DBEAFE"/>
+          </a:solidFill>
+          <a:ln/>
+        </p:spPr>
+      </p:sp>
+      <p:sp>
+        <p:nvSpPr>
+          <p:cNvPr id="38" name="Text 36"/>
+          <p:cNvSpPr/>
+          <p:nvPr/>
+        </p:nvSpPr>
+        <p:spPr>
+          <a:xfrm>
+            <a:off x="301752" y="4315968"/>
+            <a:ext cx="2048256" cy="256032"/>
+          </a:xfrm>
+          <a:prstGeom prst="rect">
+            <a:avLst/>
+          </a:prstGeom>
+          <a:noFill/>
+          <a:ln/>
+        </p:spPr>
+        <p:txBody>
+          <a:bodyPr wrap="square" rtlCol="0" anchor="ctr"/>
+          <a:lstStyle/>
+          <a:p>
+            <a:pPr algn="ctr" indent="0" marL="0">
+              <a:buNone/>
+            </a:pPr>
+            <a:r>
+              <a:rPr lang="en-US" sz="750" b="1" dirty="0">
+                <a:solidFill>
+                  <a:srgbClr val="0369A1"/>
+                </a:solidFill>
+                <a:latin typeface="Calibri" pitchFamily="34" charset="0"/>
+                <a:ea typeface="Calibri" pitchFamily="34" charset="-122"/>
+                <a:cs typeface="Calibri" pitchFamily="34" charset="-120"/>
+              </a:rPr>
+              <a:t>PRO</a:t>
+            </a:r>
+            <a:endParaRPr lang="en-US" sz="750" dirty="0"/>
+          </a:p>
+        </p:txBody>
+      </p:sp>
+      <p:sp>
+        <p:nvSpPr>
+          <p:cNvPr id="39" name="Shape 37"/>
+          <p:cNvSpPr/>
+          <p:nvPr/>
+        </p:nvSpPr>
+        <p:spPr>
+          <a:xfrm>
+            <a:off x="2578608" y="3200400"/>
+            <a:ext cx="2194560" cy="1536192"/>
+          </a:xfrm>
+          <a:prstGeom prst="rect">
+            <a:avLst>
+              <a:gd name="adj" fmla="val 4762"/>
+            </a:avLst>
+          </a:prstGeom>
+          <a:solidFill>
+            <a:srgbClr val="EFF6FF"/>
           </a:solidFill>
           <a:ln w="12700">
             <a:solidFill>
@@ -21263,14 +21851,14 @@
       </p:sp>
       <p:sp>
         <p:nvSpPr>
-          <p:cNvPr id="21" name="Text 19"/>
-          <p:cNvSpPr/>
-          <p:nvPr/>
-        </p:nvSpPr>
-        <p:spPr>
-          <a:xfrm>
-            <a:off x="2578608" y="2926080"/>
-            <a:ext cx="2194560" cy="1234440"/>
+          <p:cNvPr id="40" name="Text 38"/>
+          <p:cNvSpPr/>
+          <p:nvPr/>
+        </p:nvSpPr>
+        <p:spPr>
+          <a:xfrm>
+            <a:off x="2651760" y="3310128"/>
+            <a:ext cx="2048256" cy="1005840"/>
           </a:xfrm>
           <a:prstGeom prst="rect">
             <a:avLst/>
@@ -21288,13 +21876,13 @@
             <a:r>
               <a:rPr lang="en-US" sz="1050" b="1" dirty="0">
                 <a:solidFill>
-                  <a:srgbClr val="1E3A5F"/>
-                </a:solidFill>
-                <a:latin typeface="Calibri" pitchFamily="34" charset="0"/>
-                <a:ea typeface="Calibri" pitchFamily="34" charset="-122"/>
-                <a:cs typeface="Calibri" pitchFamily="34" charset="-120"/>
-              </a:rPr>
-              <a:t>Double-Entry Accounting</a:t>
+                  <a:srgbClr val="0369A1"/>
+                </a:solidFill>
+                <a:latin typeface="Calibri" pitchFamily="34" charset="0"/>
+                <a:ea typeface="Calibri" pitchFamily="34" charset="-122"/>
+                <a:cs typeface="Calibri" pitchFamily="34" charset="-120"/>
+              </a:rPr>
+              <a:t>Quality &amp; Returns</a:t>
             </a:r>
             <a:endParaRPr lang="en-US" sz="1050" dirty="0"/>
           </a:p>
@@ -21302,22 +21890,83 @@
       </p:sp>
       <p:sp>
         <p:nvSpPr>
-          <p:cNvPr id="22" name="Shape 20"/>
-          <p:cNvSpPr/>
-          <p:nvPr/>
-        </p:nvSpPr>
-        <p:spPr>
-          <a:xfrm>
-            <a:off x="4928616" y="2834640"/>
-            <a:ext cx="2194560" cy="1417320"/>
+          <p:cNvPr id="41" name="Shape 39"/>
+          <p:cNvSpPr/>
+          <p:nvPr/>
+        </p:nvSpPr>
+        <p:spPr>
+          <a:xfrm>
+            <a:off x="2651760" y="4315968"/>
+            <a:ext cx="2048256" cy="256032"/>
           </a:xfrm>
           <a:prstGeom prst="rect">
             <a:avLst>
-              <a:gd name="adj" fmla="val 5161"/>
+              <a:gd name="adj" fmla="val 14286"/>
             </a:avLst>
           </a:prstGeom>
           <a:solidFill>
-            <a:srgbClr val="FFFFFF"/>
+            <a:srgbClr val="DBEAFE"/>
+          </a:solidFill>
+          <a:ln/>
+        </p:spPr>
+      </p:sp>
+      <p:sp>
+        <p:nvSpPr>
+          <p:cNvPr id="42" name="Text 40"/>
+          <p:cNvSpPr/>
+          <p:nvPr/>
+        </p:nvSpPr>
+        <p:spPr>
+          <a:xfrm>
+            <a:off x="2651760" y="4315968"/>
+            <a:ext cx="2048256" cy="256032"/>
+          </a:xfrm>
+          <a:prstGeom prst="rect">
+            <a:avLst/>
+          </a:prstGeom>
+          <a:noFill/>
+          <a:ln/>
+        </p:spPr>
+        <p:txBody>
+          <a:bodyPr wrap="square" rtlCol="0" anchor="ctr"/>
+          <a:lstStyle/>
+          <a:p>
+            <a:pPr algn="ctr" indent="0" marL="0">
+              <a:buNone/>
+            </a:pPr>
+            <a:r>
+              <a:rPr lang="en-US" sz="750" b="1" dirty="0">
+                <a:solidFill>
+                  <a:srgbClr val="0369A1"/>
+                </a:solidFill>
+                <a:latin typeface="Calibri" pitchFamily="34" charset="0"/>
+                <a:ea typeface="Calibri" pitchFamily="34" charset="-122"/>
+                <a:cs typeface="Calibri" pitchFamily="34" charset="-120"/>
+              </a:rPr>
+              <a:t>PRO</a:t>
+            </a:r>
+            <a:endParaRPr lang="en-US" sz="750" dirty="0"/>
+          </a:p>
+        </p:txBody>
+      </p:sp>
+      <p:sp>
+        <p:nvSpPr>
+          <p:cNvPr id="43" name="Shape 41"/>
+          <p:cNvSpPr/>
+          <p:nvPr/>
+        </p:nvSpPr>
+        <p:spPr>
+          <a:xfrm>
+            <a:off x="4928616" y="3200400"/>
+            <a:ext cx="2194560" cy="1536192"/>
+          </a:xfrm>
+          <a:prstGeom prst="rect">
+            <a:avLst>
+              <a:gd name="adj" fmla="val 4762"/>
+            </a:avLst>
+          </a:prstGeom>
+          <a:solidFill>
+            <a:srgbClr val="EFF6FF"/>
           </a:solidFill>
           <a:ln w="12700">
             <a:solidFill>
@@ -21329,14 +21978,14 @@
       </p:sp>
       <p:sp>
         <p:nvSpPr>
-          <p:cNvPr id="23" name="Text 21"/>
-          <p:cNvSpPr/>
-          <p:nvPr/>
-        </p:nvSpPr>
-        <p:spPr>
-          <a:xfrm>
-            <a:off x="4928616" y="2926080"/>
-            <a:ext cx="2194560" cy="1234440"/>
+          <p:cNvPr id="44" name="Text 42"/>
+          <p:cNvSpPr/>
+          <p:nvPr/>
+        </p:nvSpPr>
+        <p:spPr>
+          <a:xfrm>
+            <a:off x="5001768" y="3310128"/>
+            <a:ext cx="2048256" cy="1005840"/>
           </a:xfrm>
           <a:prstGeom prst="rect">
             <a:avLst/>
@@ -21354,13 +22003,13 @@
             <a:r>
               <a:rPr lang="en-US" sz="1050" b="1" dirty="0">
                 <a:solidFill>
-                  <a:srgbClr val="1E3A5F"/>
-                </a:solidFill>
-                <a:latin typeface="Calibri" pitchFamily="34" charset="0"/>
-                <a:ea typeface="Calibri" pitchFamily="34" charset="-122"/>
-                <a:cs typeface="Calibri" pitchFamily="34" charset="-120"/>
-              </a:rPr>
-              <a:t>MIS Analytics</a:t>
+                  <a:srgbClr val="0369A1"/>
+                </a:solidFill>
+                <a:latin typeface="Calibri" pitchFamily="34" charset="0"/>
+                <a:ea typeface="Calibri" pitchFamily="34" charset="-122"/>
+                <a:cs typeface="Calibri" pitchFamily="34" charset="-120"/>
+              </a:rPr>
+              <a:t>Double-Entry Accounting</a:t>
             </a:r>
             <a:endParaRPr lang="en-US" sz="1050" dirty="0"/>
           </a:p>
@@ -21368,22 +22017,83 @@
       </p:sp>
       <p:sp>
         <p:nvSpPr>
-          <p:cNvPr id="24" name="Shape 22"/>
-          <p:cNvSpPr/>
-          <p:nvPr/>
-        </p:nvSpPr>
-        <p:spPr>
-          <a:xfrm>
-            <a:off x="7278624" y="2834640"/>
-            <a:ext cx="2194560" cy="1417320"/>
+          <p:cNvPr id="45" name="Shape 43"/>
+          <p:cNvSpPr/>
+          <p:nvPr/>
+        </p:nvSpPr>
+        <p:spPr>
+          <a:xfrm>
+            <a:off x="5001768" y="4315968"/>
+            <a:ext cx="2048256" cy="256032"/>
           </a:xfrm>
           <a:prstGeom prst="rect">
             <a:avLst>
-              <a:gd name="adj" fmla="val 5161"/>
+              <a:gd name="adj" fmla="val 14286"/>
             </a:avLst>
           </a:prstGeom>
           <a:solidFill>
-            <a:srgbClr val="FFFFFF"/>
+            <a:srgbClr val="DBEAFE"/>
+          </a:solidFill>
+          <a:ln/>
+        </p:spPr>
+      </p:sp>
+      <p:sp>
+        <p:nvSpPr>
+          <p:cNvPr id="46" name="Text 44"/>
+          <p:cNvSpPr/>
+          <p:nvPr/>
+        </p:nvSpPr>
+        <p:spPr>
+          <a:xfrm>
+            <a:off x="5001768" y="4315968"/>
+            <a:ext cx="2048256" cy="256032"/>
+          </a:xfrm>
+          <a:prstGeom prst="rect">
+            <a:avLst/>
+          </a:prstGeom>
+          <a:noFill/>
+          <a:ln/>
+        </p:spPr>
+        <p:txBody>
+          <a:bodyPr wrap="square" rtlCol="0" anchor="ctr"/>
+          <a:lstStyle/>
+          <a:p>
+            <a:pPr algn="ctr" indent="0" marL="0">
+              <a:buNone/>
+            </a:pPr>
+            <a:r>
+              <a:rPr lang="en-US" sz="750" b="1" dirty="0">
+                <a:solidFill>
+                  <a:srgbClr val="0369A1"/>
+                </a:solidFill>
+                <a:latin typeface="Calibri" pitchFamily="34" charset="0"/>
+                <a:ea typeface="Calibri" pitchFamily="34" charset="-122"/>
+                <a:cs typeface="Calibri" pitchFamily="34" charset="-120"/>
+              </a:rPr>
+              <a:t>PRO</a:t>
+            </a:r>
+            <a:endParaRPr lang="en-US" sz="750" dirty="0"/>
+          </a:p>
+        </p:txBody>
+      </p:sp>
+      <p:sp>
+        <p:nvSpPr>
+          <p:cNvPr id="47" name="Shape 45"/>
+          <p:cNvSpPr/>
+          <p:nvPr/>
+        </p:nvSpPr>
+        <p:spPr>
+          <a:xfrm>
+            <a:off x="7278624" y="3200400"/>
+            <a:ext cx="2194560" cy="1536192"/>
+          </a:xfrm>
+          <a:prstGeom prst="rect">
+            <a:avLst>
+              <a:gd name="adj" fmla="val 4762"/>
+            </a:avLst>
+          </a:prstGeom>
+          <a:solidFill>
+            <a:srgbClr val="EFF6FF"/>
           </a:solidFill>
           <a:ln w="12700">
             <a:solidFill>
@@ -21395,14 +22105,14 @@
       </p:sp>
       <p:sp>
         <p:nvSpPr>
-          <p:cNvPr id="25" name="Text 23"/>
-          <p:cNvSpPr/>
-          <p:nvPr/>
-        </p:nvSpPr>
-        <p:spPr>
-          <a:xfrm>
-            <a:off x="7278624" y="2926080"/>
-            <a:ext cx="2194560" cy="1234440"/>
+          <p:cNvPr id="48" name="Text 46"/>
+          <p:cNvSpPr/>
+          <p:nvPr/>
+        </p:nvSpPr>
+        <p:spPr>
+          <a:xfrm>
+            <a:off x="7351776" y="3310128"/>
+            <a:ext cx="2048256" cy="1005840"/>
           </a:xfrm>
           <a:prstGeom prst="rect">
             <a:avLst/>
@@ -21420,13 +22130,13 @@
             <a:r>
               <a:rPr lang="en-US" sz="1050" b="1" dirty="0">
                 <a:solidFill>
-                  <a:srgbClr val="1E3A5F"/>
-                </a:solidFill>
-                <a:latin typeface="Calibri" pitchFamily="34" charset="0"/>
-                <a:ea typeface="Calibri" pitchFamily="34" charset="-122"/>
-                <a:cs typeface="Calibri" pitchFamily="34" charset="-120"/>
-              </a:rPr>
-              <a:t>Preventive Maintenance</a:t>
+                  <a:srgbClr val="0369A1"/>
+                </a:solidFill>
+                <a:latin typeface="Calibri" pitchFamily="34" charset="0"/>
+                <a:ea typeface="Calibri" pitchFamily="34" charset="-122"/>
+                <a:cs typeface="Calibri" pitchFamily="34" charset="-120"/>
+              </a:rPr>
+              <a:t>MIS Analytics</a:t>
             </a:r>
             <a:endParaRPr lang="en-US" sz="1050" dirty="0"/>
           </a:p>
@@ -21434,22 +22144,83 @@
       </p:sp>
       <p:sp>
         <p:nvSpPr>
-          <p:cNvPr id="26" name="Shape 24"/>
-          <p:cNvSpPr/>
-          <p:nvPr/>
-        </p:nvSpPr>
-        <p:spPr>
-          <a:xfrm>
-            <a:off x="9628632" y="2834640"/>
-            <a:ext cx="2194560" cy="1417320"/>
+          <p:cNvPr id="49" name="Shape 47"/>
+          <p:cNvSpPr/>
+          <p:nvPr/>
+        </p:nvSpPr>
+        <p:spPr>
+          <a:xfrm>
+            <a:off x="7351776" y="4315968"/>
+            <a:ext cx="2048256" cy="256032"/>
           </a:xfrm>
           <a:prstGeom prst="rect">
             <a:avLst>
-              <a:gd name="adj" fmla="val 5161"/>
+              <a:gd name="adj" fmla="val 14286"/>
             </a:avLst>
           </a:prstGeom>
           <a:solidFill>
-            <a:srgbClr val="FFFFFF"/>
+            <a:srgbClr val="DBEAFE"/>
+          </a:solidFill>
+          <a:ln/>
+        </p:spPr>
+      </p:sp>
+      <p:sp>
+        <p:nvSpPr>
+          <p:cNvPr id="50" name="Text 48"/>
+          <p:cNvSpPr/>
+          <p:nvPr/>
+        </p:nvSpPr>
+        <p:spPr>
+          <a:xfrm>
+            <a:off x="7351776" y="4315968"/>
+            <a:ext cx="2048256" cy="256032"/>
+          </a:xfrm>
+          <a:prstGeom prst="rect">
+            <a:avLst/>
+          </a:prstGeom>
+          <a:noFill/>
+          <a:ln/>
+        </p:spPr>
+        <p:txBody>
+          <a:bodyPr wrap="square" rtlCol="0" anchor="ctr"/>
+          <a:lstStyle/>
+          <a:p>
+            <a:pPr algn="ctr" indent="0" marL="0">
+              <a:buNone/>
+            </a:pPr>
+            <a:r>
+              <a:rPr lang="en-US" sz="750" b="1" dirty="0">
+                <a:solidFill>
+                  <a:srgbClr val="0369A1"/>
+                </a:solidFill>
+                <a:latin typeface="Calibri" pitchFamily="34" charset="0"/>
+                <a:ea typeface="Calibri" pitchFamily="34" charset="-122"/>
+                <a:cs typeface="Calibri" pitchFamily="34" charset="-120"/>
+              </a:rPr>
+              <a:t>PRO</a:t>
+            </a:r>
+            <a:endParaRPr lang="en-US" sz="750" dirty="0"/>
+          </a:p>
+        </p:txBody>
+      </p:sp>
+      <p:sp>
+        <p:nvSpPr>
+          <p:cNvPr id="51" name="Shape 49"/>
+          <p:cNvSpPr/>
+          <p:nvPr/>
+        </p:nvSpPr>
+        <p:spPr>
+          <a:xfrm>
+            <a:off x="9628632" y="3200400"/>
+            <a:ext cx="2194560" cy="1536192"/>
+          </a:xfrm>
+          <a:prstGeom prst="rect">
+            <a:avLst>
+              <a:gd name="adj" fmla="val 4762"/>
+            </a:avLst>
+          </a:prstGeom>
+          <a:solidFill>
+            <a:srgbClr val="EFF6FF"/>
           </a:solidFill>
           <a:ln w="12700">
             <a:solidFill>
@@ -21461,14 +22232,14 @@
       </p:sp>
       <p:sp>
         <p:nvSpPr>
-          <p:cNvPr id="27" name="Text 25"/>
-          <p:cNvSpPr/>
-          <p:nvPr/>
-        </p:nvSpPr>
-        <p:spPr>
-          <a:xfrm>
-            <a:off x="9628632" y="2926080"/>
-            <a:ext cx="2194560" cy="1234440"/>
+          <p:cNvPr id="52" name="Text 50"/>
+          <p:cNvSpPr/>
+          <p:nvPr/>
+        </p:nvSpPr>
+        <p:spPr>
+          <a:xfrm>
+            <a:off x="9701784" y="3310128"/>
+            <a:ext cx="2048256" cy="1005840"/>
           </a:xfrm>
           <a:prstGeom prst="rect">
             <a:avLst/>
@@ -21486,7 +22257,7 @@
             <a:r>
               <a:rPr lang="en-US" sz="1050" b="1" dirty="0">
                 <a:solidFill>
-                  <a:srgbClr val="1E3A5F"/>
+                  <a:srgbClr val="0369A1"/>
                 </a:solidFill>
                 <a:latin typeface="Calibri" pitchFamily="34" charset="0"/>
                 <a:ea typeface="Calibri" pitchFamily="34" charset="-122"/>
@@ -21500,22 +22271,83 @@
       </p:sp>
       <p:sp>
         <p:nvSpPr>
-          <p:cNvPr id="28" name="Shape 26"/>
-          <p:cNvSpPr/>
-          <p:nvPr/>
-        </p:nvSpPr>
-        <p:spPr>
-          <a:xfrm>
-            <a:off x="228600" y="4434840"/>
-            <a:ext cx="2194560" cy="1417320"/>
+          <p:cNvPr id="53" name="Shape 51"/>
+          <p:cNvSpPr/>
+          <p:nvPr/>
+        </p:nvSpPr>
+        <p:spPr>
+          <a:xfrm>
+            <a:off x="9701784" y="4315968"/>
+            <a:ext cx="2048256" cy="256032"/>
           </a:xfrm>
           <a:prstGeom prst="rect">
             <a:avLst>
-              <a:gd name="adj" fmla="val 5161"/>
+              <a:gd name="adj" fmla="val 14286"/>
             </a:avLst>
           </a:prstGeom>
           <a:solidFill>
-            <a:srgbClr val="FFFFFF"/>
+            <a:srgbClr val="DBEAFE"/>
+          </a:solidFill>
+          <a:ln/>
+        </p:spPr>
+      </p:sp>
+      <p:sp>
+        <p:nvSpPr>
+          <p:cNvPr id="54" name="Text 52"/>
+          <p:cNvSpPr/>
+          <p:nvPr/>
+        </p:nvSpPr>
+        <p:spPr>
+          <a:xfrm>
+            <a:off x="9701784" y="4315968"/>
+            <a:ext cx="2048256" cy="256032"/>
+          </a:xfrm>
+          <a:prstGeom prst="rect">
+            <a:avLst/>
+          </a:prstGeom>
+          <a:noFill/>
+          <a:ln/>
+        </p:spPr>
+        <p:txBody>
+          <a:bodyPr wrap="square" rtlCol="0" anchor="ctr"/>
+          <a:lstStyle/>
+          <a:p>
+            <a:pPr algn="ctr" indent="0" marL="0">
+              <a:buNone/>
+            </a:pPr>
+            <a:r>
+              <a:rPr lang="en-US" sz="750" b="1" dirty="0">
+                <a:solidFill>
+                  <a:srgbClr val="0369A1"/>
+                </a:solidFill>
+                <a:latin typeface="Calibri" pitchFamily="34" charset="0"/>
+                <a:ea typeface="Calibri" pitchFamily="34" charset="-122"/>
+                <a:cs typeface="Calibri" pitchFamily="34" charset="-120"/>
+              </a:rPr>
+              <a:t>PRO</a:t>
+            </a:r>
+            <a:endParaRPr lang="en-US" sz="750" dirty="0"/>
+          </a:p>
+        </p:txBody>
+      </p:sp>
+      <p:sp>
+        <p:nvSpPr>
+          <p:cNvPr id="55" name="Shape 53"/>
+          <p:cNvSpPr/>
+          <p:nvPr/>
+        </p:nvSpPr>
+        <p:spPr>
+          <a:xfrm>
+            <a:off x="228600" y="4919472"/>
+            <a:ext cx="2194560" cy="1536192"/>
+          </a:xfrm>
+          <a:prstGeom prst="rect">
+            <a:avLst>
+              <a:gd name="adj" fmla="val 4762"/>
+            </a:avLst>
+          </a:prstGeom>
+          <a:solidFill>
+            <a:srgbClr val="EFF6FF"/>
           </a:solidFill>
           <a:ln w="12700">
             <a:solidFill>
@@ -21527,14 +22359,14 @@
       </p:sp>
       <p:sp>
         <p:nvSpPr>
-          <p:cNvPr id="29" name="Text 27"/>
-          <p:cNvSpPr/>
-          <p:nvPr/>
-        </p:nvSpPr>
-        <p:spPr>
-          <a:xfrm>
-            <a:off x="228600" y="4526280"/>
-            <a:ext cx="2194560" cy="1234440"/>
+          <p:cNvPr id="56" name="Text 54"/>
+          <p:cNvSpPr/>
+          <p:nvPr/>
+        </p:nvSpPr>
+        <p:spPr>
+          <a:xfrm>
+            <a:off x="301752" y="5029200"/>
+            <a:ext cx="2048256" cy="1005840"/>
           </a:xfrm>
           <a:prstGeom prst="rect">
             <a:avLst/>
@@ -21552,13 +22384,13 @@
             <a:r>
               <a:rPr lang="en-US" sz="1050" b="1" dirty="0">
                 <a:solidFill>
-                  <a:srgbClr val="1E3A5F"/>
-                </a:solidFill>
-                <a:latin typeface="Calibri" pitchFamily="34" charset="0"/>
-                <a:ea typeface="Calibri" pitchFamily="34" charset="-122"/>
-                <a:cs typeface="Calibri" pitchFamily="34" charset="-120"/>
-              </a:rPr>
-              <a:t>Expenses &amp; Cash Register</a:t>
+                  <a:srgbClr val="0369A1"/>
+                </a:solidFill>
+                <a:latin typeface="Calibri" pitchFamily="34" charset="0"/>
+                <a:ea typeface="Calibri" pitchFamily="34" charset="-122"/>
+                <a:cs typeface="Calibri" pitchFamily="34" charset="-120"/>
+              </a:rPr>
+              <a:t>Preventive Maintenance</a:t>
             </a:r>
             <a:endParaRPr lang="en-US" sz="1050" dirty="0"/>
           </a:p>
@@ -21566,22 +22398,83 @@
       </p:sp>
       <p:sp>
         <p:nvSpPr>
-          <p:cNvPr id="30" name="Shape 28"/>
-          <p:cNvSpPr/>
-          <p:nvPr/>
-        </p:nvSpPr>
-        <p:spPr>
-          <a:xfrm>
-            <a:off x="2578608" y="4434840"/>
-            <a:ext cx="2194560" cy="1417320"/>
+          <p:cNvPr id="57" name="Shape 55"/>
+          <p:cNvSpPr/>
+          <p:nvPr/>
+        </p:nvSpPr>
+        <p:spPr>
+          <a:xfrm>
+            <a:off x="301752" y="6035040"/>
+            <a:ext cx="2048256" cy="256032"/>
           </a:xfrm>
           <a:prstGeom prst="rect">
             <a:avLst>
-              <a:gd name="adj" fmla="val 5161"/>
+              <a:gd name="adj" fmla="val 14286"/>
             </a:avLst>
           </a:prstGeom>
           <a:solidFill>
-            <a:srgbClr val="FFFFFF"/>
+            <a:srgbClr val="DBEAFE"/>
+          </a:solidFill>
+          <a:ln/>
+        </p:spPr>
+      </p:sp>
+      <p:sp>
+        <p:nvSpPr>
+          <p:cNvPr id="58" name="Text 56"/>
+          <p:cNvSpPr/>
+          <p:nvPr/>
+        </p:nvSpPr>
+        <p:spPr>
+          <a:xfrm>
+            <a:off x="301752" y="6035040"/>
+            <a:ext cx="2048256" cy="256032"/>
+          </a:xfrm>
+          <a:prstGeom prst="rect">
+            <a:avLst/>
+          </a:prstGeom>
+          <a:noFill/>
+          <a:ln/>
+        </p:spPr>
+        <p:txBody>
+          <a:bodyPr wrap="square" rtlCol="0" anchor="ctr"/>
+          <a:lstStyle/>
+          <a:p>
+            <a:pPr algn="ctr" indent="0" marL="0">
+              <a:buNone/>
+            </a:pPr>
+            <a:r>
+              <a:rPr lang="en-US" sz="750" b="1" dirty="0">
+                <a:solidFill>
+                  <a:srgbClr val="0369A1"/>
+                </a:solidFill>
+                <a:latin typeface="Calibri" pitchFamily="34" charset="0"/>
+                <a:ea typeface="Calibri" pitchFamily="34" charset="-122"/>
+                <a:cs typeface="Calibri" pitchFamily="34" charset="-120"/>
+              </a:rPr>
+              <a:t>PRO</a:t>
+            </a:r>
+            <a:endParaRPr lang="en-US" sz="750" dirty="0"/>
+          </a:p>
+        </p:txBody>
+      </p:sp>
+      <p:sp>
+        <p:nvSpPr>
+          <p:cNvPr id="59" name="Shape 57"/>
+          <p:cNvSpPr/>
+          <p:nvPr/>
+        </p:nvSpPr>
+        <p:spPr>
+          <a:xfrm>
+            <a:off x="2578608" y="4919472"/>
+            <a:ext cx="2194560" cy="1536192"/>
+          </a:xfrm>
+          <a:prstGeom prst="rect">
+            <a:avLst>
+              <a:gd name="adj" fmla="val 4762"/>
+            </a:avLst>
+          </a:prstGeom>
+          <a:solidFill>
+            <a:srgbClr val="EFF6FF"/>
           </a:solidFill>
           <a:ln w="12700">
             <a:solidFill>
@@ -21593,14 +22486,14 @@
       </p:sp>
       <p:sp>
         <p:nvSpPr>
-          <p:cNvPr id="31" name="Text 29"/>
-          <p:cNvSpPr/>
-          <p:nvPr/>
-        </p:nvSpPr>
-        <p:spPr>
-          <a:xfrm>
-            <a:off x="2578608" y="4526280"/>
-            <a:ext cx="2194560" cy="1234440"/>
+          <p:cNvPr id="60" name="Text 58"/>
+          <p:cNvSpPr/>
+          <p:nvPr/>
+        </p:nvSpPr>
+        <p:spPr>
+          <a:xfrm>
+            <a:off x="2651760" y="5029200"/>
+            <a:ext cx="2048256" cy="1005840"/>
           </a:xfrm>
           <a:prstGeom prst="rect">
             <a:avLst/>
@@ -21618,13 +22511,13 @@
             <a:r>
               <a:rPr lang="en-US" sz="1050" b="1" dirty="0">
                 <a:solidFill>
-                  <a:srgbClr val="1E3A5F"/>
-                </a:solidFill>
-                <a:latin typeface="Calibri" pitchFamily="34" charset="0"/>
-                <a:ea typeface="Calibri" pitchFamily="34" charset="-122"/>
-                <a:cs typeface="Calibri" pitchFamily="34" charset="-120"/>
-              </a:rPr>
-              <a:t>Document Management</a:t>
+                  <a:srgbClr val="0369A1"/>
+                </a:solidFill>
+                <a:latin typeface="Calibri" pitchFamily="34" charset="0"/>
+                <a:ea typeface="Calibri" pitchFamily="34" charset="-122"/>
+                <a:cs typeface="Calibri" pitchFamily="34" charset="-120"/>
+              </a:rPr>
+              <a:t>CRM Lead Management</a:t>
             </a:r>
             <a:endParaRPr lang="en-US" sz="1050" dirty="0"/>
           </a:p>
@@ -21632,18 +22525,79 @@
       </p:sp>
       <p:sp>
         <p:nvSpPr>
-          <p:cNvPr id="32" name="Shape 30"/>
-          <p:cNvSpPr/>
-          <p:nvPr/>
-        </p:nvSpPr>
-        <p:spPr>
-          <a:xfrm>
-            <a:off x="4928616" y="4434840"/>
-            <a:ext cx="2194560" cy="1417320"/>
+          <p:cNvPr id="61" name="Shape 59"/>
+          <p:cNvSpPr/>
+          <p:nvPr/>
+        </p:nvSpPr>
+        <p:spPr>
+          <a:xfrm>
+            <a:off x="2651760" y="6035040"/>
+            <a:ext cx="2048256" cy="256032"/>
           </a:xfrm>
           <a:prstGeom prst="rect">
             <a:avLst>
-              <a:gd name="adj" fmla="val 5161"/>
+              <a:gd name="adj" fmla="val 14286"/>
+            </a:avLst>
+          </a:prstGeom>
+          <a:solidFill>
+            <a:srgbClr val="DBEAFE"/>
+          </a:solidFill>
+          <a:ln/>
+        </p:spPr>
+      </p:sp>
+      <p:sp>
+        <p:nvSpPr>
+          <p:cNvPr id="62" name="Text 60"/>
+          <p:cNvSpPr/>
+          <p:nvPr/>
+        </p:nvSpPr>
+        <p:spPr>
+          <a:xfrm>
+            <a:off x="2651760" y="6035040"/>
+            <a:ext cx="2048256" cy="256032"/>
+          </a:xfrm>
+          <a:prstGeom prst="rect">
+            <a:avLst/>
+          </a:prstGeom>
+          <a:noFill/>
+          <a:ln/>
+        </p:spPr>
+        <p:txBody>
+          <a:bodyPr wrap="square" rtlCol="0" anchor="ctr"/>
+          <a:lstStyle/>
+          <a:p>
+            <a:pPr algn="ctr" indent="0" marL="0">
+              <a:buNone/>
+            </a:pPr>
+            <a:r>
+              <a:rPr lang="en-US" sz="750" b="1" dirty="0">
+                <a:solidFill>
+                  <a:srgbClr val="0369A1"/>
+                </a:solidFill>
+                <a:latin typeface="Calibri" pitchFamily="34" charset="0"/>
+                <a:ea typeface="Calibri" pitchFamily="34" charset="-122"/>
+                <a:cs typeface="Calibri" pitchFamily="34" charset="-120"/>
+              </a:rPr>
+              <a:t>PRO</a:t>
+            </a:r>
+            <a:endParaRPr lang="en-US" sz="750" dirty="0"/>
+          </a:p>
+        </p:txBody>
+      </p:sp>
+      <p:sp>
+        <p:nvSpPr>
+          <p:cNvPr id="63" name="Shape 61"/>
+          <p:cNvSpPr/>
+          <p:nvPr/>
+        </p:nvSpPr>
+        <p:spPr>
+          <a:xfrm>
+            <a:off x="4928616" y="4919472"/>
+            <a:ext cx="2194560" cy="1536192"/>
+          </a:xfrm>
+          <a:prstGeom prst="rect">
+            <a:avLst>
+              <a:gd name="adj" fmla="val 4762"/>
             </a:avLst>
           </a:prstGeom>
           <a:solidFill>
@@ -21659,14 +22613,14 @@
       </p:sp>
       <p:sp>
         <p:nvSpPr>
-          <p:cNvPr id="33" name="Text 31"/>
-          <p:cNvSpPr/>
-          <p:nvPr/>
-        </p:nvSpPr>
-        <p:spPr>
-          <a:xfrm>
-            <a:off x="4928616" y="4526280"/>
-            <a:ext cx="2194560" cy="1234440"/>
+          <p:cNvPr id="64" name="Text 62"/>
+          <p:cNvSpPr/>
+          <p:nvPr/>
+        </p:nvSpPr>
+        <p:spPr>
+          <a:xfrm>
+            <a:off x="5001768" y="5029200"/>
+            <a:ext cx="2048256" cy="1005840"/>
           </a:xfrm>
           <a:prstGeom prst="rect">
             <a:avLst/>
@@ -21690,7 +22644,7 @@
                 <a:ea typeface="Calibri" pitchFamily="34" charset="-122"/>
                 <a:cs typeface="Calibri" pitchFamily="34" charset="-120"/>
               </a:rPr>
-              <a:t>CRM Lead Management</a:t>
+              <a:t>HR &amp; Payroll</a:t>
             </a:r>
             <a:endParaRPr lang="en-US" sz="1050" dirty="0"/>
           </a:p>
@@ -21698,18 +22652,18 @@
       </p:sp>
       <p:sp>
         <p:nvSpPr>
-          <p:cNvPr id="34" name="Shape 32"/>
-          <p:cNvSpPr/>
-          <p:nvPr/>
-        </p:nvSpPr>
-        <p:spPr>
-          <a:xfrm>
-            <a:off x="6300216" y="4297680"/>
-            <a:ext cx="640080" cy="201168"/>
+          <p:cNvPr id="65" name="Shape 63"/>
+          <p:cNvSpPr/>
+          <p:nvPr/>
+        </p:nvSpPr>
+        <p:spPr>
+          <a:xfrm>
+            <a:off x="5001768" y="6035040"/>
+            <a:ext cx="2048256" cy="256032"/>
           </a:xfrm>
           <a:prstGeom prst="rect">
             <a:avLst>
-              <a:gd name="adj" fmla="val 18182"/>
+              <a:gd name="adj" fmla="val 14286"/>
             </a:avLst>
           </a:prstGeom>
           <a:solidFill>
@@ -21720,14 +22674,14 @@
       </p:sp>
       <p:sp>
         <p:nvSpPr>
-          <p:cNvPr id="35" name="Text 33"/>
-          <p:cNvSpPr/>
-          <p:nvPr/>
-        </p:nvSpPr>
-        <p:spPr>
-          <a:xfrm>
-            <a:off x="6300216" y="4297680"/>
-            <a:ext cx="640080" cy="201168"/>
+          <p:cNvPr id="66" name="Text 64"/>
+          <p:cNvSpPr/>
+          <p:nvPr/>
+        </p:nvSpPr>
+        <p:spPr>
+          <a:xfrm>
+            <a:off x="5001768" y="6035040"/>
+            <a:ext cx="2048256" cy="256032"/>
           </a:xfrm>
           <a:prstGeom prst="rect">
             <a:avLst/>
@@ -21743,7 +22697,7 @@
               <a:buNone/>
             </a:pPr>
             <a:r>
-              <a:rPr lang="en-US" sz="700" b="1" dirty="0">
+              <a:rPr lang="en-US" sz="750" b="1" dirty="0">
                 <a:solidFill>
                   <a:srgbClr val="1E293B"/>
                 </a:solidFill>
@@ -21751,26 +22705,26 @@
                 <a:ea typeface="Calibri" pitchFamily="34" charset="-122"/>
                 <a:cs typeface="Calibri" pitchFamily="34" charset="-120"/>
               </a:rPr>
-              <a:t>NEW</a:t>
-            </a:r>
-            <a:endParaRPr lang="en-US" sz="700" dirty="0"/>
-          </a:p>
-        </p:txBody>
-      </p:sp>
-      <p:sp>
-        <p:nvSpPr>
-          <p:cNvPr id="36" name="Shape 34"/>
-          <p:cNvSpPr/>
-          <p:nvPr/>
-        </p:nvSpPr>
-        <p:spPr>
-          <a:xfrm>
-            <a:off x="7278624" y="4434840"/>
-            <a:ext cx="2194560" cy="1417320"/>
+              <a:t>ENTERPRISE</a:t>
+            </a:r>
+            <a:endParaRPr lang="en-US" sz="750" dirty="0"/>
+          </a:p>
+        </p:txBody>
+      </p:sp>
+      <p:sp>
+        <p:nvSpPr>
+          <p:cNvPr id="67" name="Shape 65"/>
+          <p:cNvSpPr/>
+          <p:nvPr/>
+        </p:nvSpPr>
+        <p:spPr>
+          <a:xfrm>
+            <a:off x="7278624" y="4919472"/>
+            <a:ext cx="2194560" cy="1536192"/>
           </a:xfrm>
           <a:prstGeom prst="rect">
             <a:avLst>
-              <a:gd name="adj" fmla="val 5161"/>
+              <a:gd name="adj" fmla="val 4762"/>
             </a:avLst>
           </a:prstGeom>
           <a:solidFill>
@@ -21786,14 +22740,14 @@
       </p:sp>
       <p:sp>
         <p:nvSpPr>
-          <p:cNvPr id="37" name="Text 35"/>
-          <p:cNvSpPr/>
-          <p:nvPr/>
-        </p:nvSpPr>
-        <p:spPr>
-          <a:xfrm>
-            <a:off x="7278624" y="4526280"/>
-            <a:ext cx="2194560" cy="1234440"/>
+          <p:cNvPr id="68" name="Text 66"/>
+          <p:cNvSpPr/>
+          <p:nvPr/>
+        </p:nvSpPr>
+        <p:spPr>
+          <a:xfrm>
+            <a:off x="7351776" y="5029200"/>
+            <a:ext cx="2048256" cy="1005840"/>
           </a:xfrm>
           <a:prstGeom prst="rect">
             <a:avLst/>
@@ -21817,7 +22771,7 @@
                 <a:ea typeface="Calibri" pitchFamily="34" charset="-122"/>
                 <a:cs typeface="Calibri" pitchFamily="34" charset="-120"/>
               </a:rPr>
-              <a:t>HR &amp; Payroll</a:t>
+              <a:t>Employee Self-Service</a:t>
             </a:r>
             <a:endParaRPr lang="en-US" sz="1050" dirty="0"/>
           </a:p>
@@ -21825,18 +22779,18 @@
       </p:sp>
       <p:sp>
         <p:nvSpPr>
-          <p:cNvPr id="38" name="Shape 36"/>
-          <p:cNvSpPr/>
-          <p:nvPr/>
-        </p:nvSpPr>
-        <p:spPr>
-          <a:xfrm>
-            <a:off x="8650224" y="4297680"/>
-            <a:ext cx="640080" cy="201168"/>
+          <p:cNvPr id="69" name="Shape 67"/>
+          <p:cNvSpPr/>
+          <p:nvPr/>
+        </p:nvSpPr>
+        <p:spPr>
+          <a:xfrm>
+            <a:off x="7351776" y="6035040"/>
+            <a:ext cx="2048256" cy="256032"/>
           </a:xfrm>
           <a:prstGeom prst="rect">
             <a:avLst>
-              <a:gd name="adj" fmla="val 18182"/>
+              <a:gd name="adj" fmla="val 14286"/>
             </a:avLst>
           </a:prstGeom>
           <a:solidFill>
@@ -21847,14 +22801,14 @@
       </p:sp>
       <p:sp>
         <p:nvSpPr>
-          <p:cNvPr id="39" name="Text 37"/>
-          <p:cNvSpPr/>
-          <p:nvPr/>
-        </p:nvSpPr>
-        <p:spPr>
-          <a:xfrm>
-            <a:off x="8650224" y="4297680"/>
-            <a:ext cx="640080" cy="201168"/>
+          <p:cNvPr id="70" name="Text 68"/>
+          <p:cNvSpPr/>
+          <p:nvPr/>
+        </p:nvSpPr>
+        <p:spPr>
+          <a:xfrm>
+            <a:off x="7351776" y="6035040"/>
+            <a:ext cx="2048256" cy="256032"/>
           </a:xfrm>
           <a:prstGeom prst="rect">
             <a:avLst/>
@@ -21870,7 +22824,7 @@
               <a:buNone/>
             </a:pPr>
             <a:r>
-              <a:rPr lang="en-US" sz="700" b="1" dirty="0">
+              <a:rPr lang="en-US" sz="750" b="1" dirty="0">
                 <a:solidFill>
                   <a:srgbClr val="1E293B"/>
                 </a:solidFill>
@@ -21878,26 +22832,26 @@
                 <a:ea typeface="Calibri" pitchFamily="34" charset="-122"/>
                 <a:cs typeface="Calibri" pitchFamily="34" charset="-120"/>
               </a:rPr>
-              <a:t>NEW</a:t>
-            </a:r>
-            <a:endParaRPr lang="en-US" sz="700" dirty="0"/>
-          </a:p>
-        </p:txBody>
-      </p:sp>
-      <p:sp>
-        <p:nvSpPr>
-          <p:cNvPr id="40" name="Shape 38"/>
-          <p:cNvSpPr/>
-          <p:nvPr/>
-        </p:nvSpPr>
-        <p:spPr>
-          <a:xfrm>
-            <a:off x="9628632" y="4434840"/>
-            <a:ext cx="2194560" cy="1417320"/>
+              <a:t>ENTERPRISE</a:t>
+            </a:r>
+            <a:endParaRPr lang="en-US" sz="750" dirty="0"/>
+          </a:p>
+        </p:txBody>
+      </p:sp>
+      <p:sp>
+        <p:nvSpPr>
+          <p:cNvPr id="71" name="Shape 69"/>
+          <p:cNvSpPr/>
+          <p:nvPr/>
+        </p:nvSpPr>
+        <p:spPr>
+          <a:xfrm>
+            <a:off x="9628632" y="4919472"/>
+            <a:ext cx="2194560" cy="1536192"/>
           </a:xfrm>
           <a:prstGeom prst="rect">
             <a:avLst>
-              <a:gd name="adj" fmla="val 5161"/>
+              <a:gd name="adj" fmla="val 4762"/>
             </a:avLst>
           </a:prstGeom>
           <a:solidFill>
@@ -21913,14 +22867,14 @@
       </p:sp>
       <p:sp>
         <p:nvSpPr>
-          <p:cNvPr id="41" name="Text 39"/>
-          <p:cNvSpPr/>
-          <p:nvPr/>
-        </p:nvSpPr>
-        <p:spPr>
-          <a:xfrm>
-            <a:off x="9628632" y="4526280"/>
-            <a:ext cx="2194560" cy="1234440"/>
+          <p:cNvPr id="72" name="Text 70"/>
+          <p:cNvSpPr/>
+          <p:nvPr/>
+        </p:nvSpPr>
+        <p:spPr>
+          <a:xfrm>
+            <a:off x="9701784" y="5029200"/>
+            <a:ext cx="2048256" cy="1005840"/>
           </a:xfrm>
           <a:prstGeom prst="rect">
             <a:avLst/>
@@ -21944,7 +22898,7 @@
                 <a:ea typeface="Calibri" pitchFamily="34" charset="-122"/>
                 <a:cs typeface="Calibri" pitchFamily="34" charset="-120"/>
               </a:rPr>
-              <a:t>Employee Self-Service</a:t>
+              <a:t>Document Management</a:t>
             </a:r>
             <a:endParaRPr lang="en-US" sz="1050" dirty="0"/>
           </a:p>
@@ -21952,18 +22906,18 @@
       </p:sp>
       <p:sp>
         <p:nvSpPr>
-          <p:cNvPr id="42" name="Shape 40"/>
-          <p:cNvSpPr/>
-          <p:nvPr/>
-        </p:nvSpPr>
-        <p:spPr>
-          <a:xfrm>
-            <a:off x="11000232" y="4297680"/>
-            <a:ext cx="640080" cy="201168"/>
+          <p:cNvPr id="73" name="Shape 71"/>
+          <p:cNvSpPr/>
+          <p:nvPr/>
+        </p:nvSpPr>
+        <p:spPr>
+          <a:xfrm>
+            <a:off x="9701784" y="6035040"/>
+            <a:ext cx="2048256" cy="256032"/>
           </a:xfrm>
           <a:prstGeom prst="rect">
             <a:avLst>
-              <a:gd name="adj" fmla="val 18182"/>
+              <a:gd name="adj" fmla="val 14286"/>
             </a:avLst>
           </a:prstGeom>
           <a:solidFill>
@@ -21974,14 +22928,14 @@
       </p:sp>
       <p:sp>
         <p:nvSpPr>
-          <p:cNvPr id="43" name="Text 41"/>
-          <p:cNvSpPr/>
-          <p:nvPr/>
-        </p:nvSpPr>
-        <p:spPr>
-          <a:xfrm>
-            <a:off x="11000232" y="4297680"/>
-            <a:ext cx="640080" cy="201168"/>
+          <p:cNvPr id="74" name="Text 72"/>
+          <p:cNvSpPr/>
+          <p:nvPr/>
+        </p:nvSpPr>
+        <p:spPr>
+          <a:xfrm>
+            <a:off x="9701784" y="6035040"/>
+            <a:ext cx="2048256" cy="256032"/>
           </a:xfrm>
           <a:prstGeom prst="rect">
             <a:avLst/>
@@ -21997,7 +22951,7 @@
               <a:buNone/>
             </a:pPr>
             <a:r>
-              <a:rPr lang="en-US" sz="700" b="1" dirty="0">
+              <a:rPr lang="en-US" sz="750" b="1" dirty="0">
                 <a:solidFill>
                   <a:srgbClr val="1E293B"/>
                 </a:solidFill>
@@ -22005,9 +22959,9 @@
                 <a:ea typeface="Calibri" pitchFamily="34" charset="-122"/>
                 <a:cs typeface="Calibri" pitchFamily="34" charset="-120"/>
               </a:rPr>
-              <a:t>NEW</a:t>
-            </a:r>
-            <a:endParaRPr lang="en-US" sz="700" dirty="0"/>
+              <a:t>ENTERPRISE</a:t>
+            </a:r>
+            <a:endParaRPr lang="en-US" sz="750" dirty="0"/>
           </a:p>
         </p:txBody>
       </p:sp>

</xml_diff>